<commit_message>
Align Eureka materials with reviewer feedback
</commit_message>
<xml_diff>
--- a/DrillLoop_Business_Review.pptx
+++ b/DrillLoop_Business_Review.pptx
@@ -431,450 +431,6 @@
                 </c:pt>
                 <c:pt idx="3">
                   <c:v>3</c:v>
-                </c:pt>
-              </c:numCache>
-            </c:numRef>
-          </c:val>
-          <c:smooth val="0"/>
-          <c:extLst>
-            <c:ext uri="{C3380CC4-5D6E-409C-BE32-E72D297353CC}">
-              <c16:uniqueId val="{00000001-230A-0D4B-B6D2-57328A27E5E2}"/>
-            </c:ext>
-          </c:extLst>
-        </c:ser>
-        <c:dLbls>
-          <c:showLegendKey val="0"/>
-          <c:showVal val="0"/>
-          <c:showCatName val="0"/>
-          <c:showSerName val="0"/>
-          <c:showPercent val="0"/>
-          <c:showBubbleSize val="0"/>
-        </c:dLbls>
-        <c:marker val="1"/>
-        <c:smooth val="0"/>
-        <c:axId val="1785928255"/>
-        <c:axId val="1769229823"/>
-      </c:lineChart>
-      <c:catAx>
-        <c:axId val="1785928255"/>
-        <c:scaling>
-          <c:orientation val="minMax"/>
-        </c:scaling>
-        <c:delete val="0"/>
-        <c:axPos val="b"/>
-        <c:numFmt formatCode="General" sourceLinked="1"/>
-        <c:majorTickMark val="none"/>
-        <c:minorTickMark val="none"/>
-        <c:tickLblPos val="nextTo"/>
-        <c:spPr>
-          <a:noFill/>
-          <a:ln w="9525" cap="flat" cmpd="sng" algn="ctr">
-            <a:solidFill>
-              <a:schemeClr val="tx1"/>
-            </a:solidFill>
-            <a:round/>
-          </a:ln>
-          <a:effectLst/>
-        </c:spPr>
-        <c:txPr>
-          <a:bodyPr rot="-60000000" spcFirstLastPara="1" vertOverflow="ellipsis" vert="horz" wrap="square" anchor="ctr" anchorCtr="1"/>
-          <a:lstStyle/>
-          <a:p>
-            <a:pPr>
-              <a:defRPr sz="1100" b="0" i="0" u="none" strike="noStrike" kern="1200" baseline="0">
-                <a:solidFill>
-                  <a:schemeClr val="tx1"/>
-                </a:solidFill>
-                <a:latin typeface="+mn-lt"/>
-                <a:ea typeface="+mn-ea"/>
-                <a:cs typeface="+mn-cs"/>
-              </a:defRPr>
-            </a:pPr>
-            <a:endParaRPr lang="en-US"/>
-          </a:p>
-        </c:txPr>
-        <c:crossAx val="1769229823"/>
-        <c:crosses val="autoZero"/>
-        <c:auto val="1"/>
-        <c:lblAlgn val="ctr"/>
-        <c:lblOffset val="100"/>
-        <c:noMultiLvlLbl val="0"/>
-      </c:catAx>
-      <c:valAx>
-        <c:axId val="1769229823"/>
-        <c:scaling>
-          <c:orientation val="minMax"/>
-        </c:scaling>
-        <c:delete val="0"/>
-        <c:axPos val="l"/>
-        <c:majorGridlines>
-          <c:spPr>
-            <a:ln w="9525" cap="flat" cmpd="sng" algn="ctr">
-              <a:noFill/>
-              <a:round/>
-            </a:ln>
-            <a:effectLst/>
-          </c:spPr>
-        </c:majorGridlines>
-        <c:numFmt formatCode="General" sourceLinked="1"/>
-        <c:majorTickMark val="none"/>
-        <c:minorTickMark val="none"/>
-        <c:tickLblPos val="nextTo"/>
-        <c:spPr>
-          <a:noFill/>
-          <a:ln>
-            <a:noFill/>
-          </a:ln>
-          <a:effectLst/>
-        </c:spPr>
-        <c:txPr>
-          <a:bodyPr rot="-60000000" spcFirstLastPara="1" vertOverflow="ellipsis" vert="horz" wrap="square" anchor="ctr" anchorCtr="1"/>
-          <a:lstStyle/>
-          <a:p>
-            <a:pPr>
-              <a:defRPr sz="1100" b="0" i="0" u="none" strike="noStrike" kern="1200" baseline="0">
-                <a:solidFill>
-                  <a:schemeClr val="tx1"/>
-                </a:solidFill>
-                <a:latin typeface="Helvetica Neue Medium" panose="02000503000000020004" pitchFamily="2" charset="0"/>
-                <a:ea typeface="Helvetica Neue Medium" panose="02000503000000020004" pitchFamily="2" charset="0"/>
-                <a:cs typeface="Helvetica Neue Medium" panose="02000503000000020004" pitchFamily="2" charset="0"/>
-              </a:defRPr>
-            </a:pPr>
-            <a:endParaRPr lang="en-US"/>
-          </a:p>
-        </c:txPr>
-        <c:crossAx val="1785928255"/>
-        <c:crosses val="autoZero"/>
-        <c:crossBetween val="between"/>
-      </c:valAx>
-      <c:spPr>
-        <a:noFill/>
-        <a:ln>
-          <a:noFill/>
-        </a:ln>
-        <a:effectLst/>
-      </c:spPr>
-    </c:plotArea>
-    <c:legend>
-      <c:legendPos val="b"/>
-      <c:layout>
-        <c:manualLayout>
-          <c:xMode val="edge"/>
-          <c:yMode val="edge"/>
-          <c:x val="0.58067453497943666"/>
-          <c:y val="2.738737462131148E-2"/>
-          <c:w val="0.39987338466900668"/>
-          <c:h val="4.6123948895864915E-2"/>
-        </c:manualLayout>
-      </c:layout>
-      <c:overlay val="0"/>
-      <c:spPr>
-        <a:noFill/>
-        <a:ln>
-          <a:noFill/>
-        </a:ln>
-        <a:effectLst/>
-      </c:spPr>
-      <c:txPr>
-        <a:bodyPr rot="0" spcFirstLastPara="1" vertOverflow="ellipsis" vert="horz" wrap="square" anchor="ctr" anchorCtr="1"/>
-        <a:lstStyle/>
-        <a:p>
-          <a:pPr>
-            <a:defRPr sz="1197" b="0" i="0" u="none" strike="noStrike" kern="1200" baseline="0">
-              <a:solidFill>
-                <a:schemeClr val="tx1">
-                  <a:lumMod val="65000"/>
-                  <a:lumOff val="35000"/>
-                </a:schemeClr>
-              </a:solidFill>
-              <a:latin typeface="+mn-lt"/>
-              <a:ea typeface="+mn-ea"/>
-              <a:cs typeface="+mn-cs"/>
-            </a:defRPr>
-          </a:pPr>
-          <a:endParaRPr lang="en-US"/>
-        </a:p>
-      </c:txPr>
-    </c:legend>
-    <c:plotVisOnly val="1"/>
-    <c:dispBlanksAs val="gap"/>
-    <c:showDLblsOverMax val="0"/>
-    <c:extLst>
-      <c:ext uri="{56B9EC1D-385E-4148-901F-78D8002777C0}">
-        <c16r3:dataDisplayOptions16>
-          <c16r3:dispNaAsBlank val="1"/>
-        </c16r3:dataDisplayOptions16>
-      </c:ext>
-    </c:extLst>
-  </c:chart>
-  <c:spPr>
-    <a:noFill/>
-    <a:ln>
-      <a:noFill/>
-    </a:ln>
-    <a:effectLst/>
-  </c:spPr>
-  <c:txPr>
-    <a:bodyPr/>
-    <a:lstStyle/>
-    <a:p>
-      <a:pPr>
-        <a:defRPr/>
-      </a:pPr>
-      <a:endParaRPr lang="en-US"/>
-    </a:p>
-  </c:txPr>
-  <c:externalData r:id="rId3">
-    <c:autoUpdate val="0"/>
-  </c:externalData>
-</c:chartSpace>
-</file>
-
-<file path=ppt/charts/chart2.xml><?xml version="1.0" encoding="utf-8"?>
-<c:chartSpace xmlns:a="http://schemas.openxmlformats.org/drawingml/2006/main" xmlns:c="http://schemas.openxmlformats.org/drawingml/2006/chart" xmlns:c14="http://schemas.microsoft.com/office/drawing/2007/8/2/chart" xmlns:c15="http://schemas.microsoft.com/office/drawing/2012/chart" xmlns:c16="http://schemas.microsoft.com/office/drawing/2014/chart" xmlns:c16r3="http://schemas.microsoft.com/office/drawing/2017/03/chart" xmlns:mc="http://schemas.openxmlformats.org/markup-compatibility/2006" xmlns:r="http://schemas.openxmlformats.org/officeDocument/2006/relationships">
-  <c:date1904 val="0"/>
-  <c:lang val="en-US"/>
-  <c:roundedCorners val="0"/>
-  <mc:AlternateContent>
-    <mc:Choice Requires="c14">
-      <c14:style val="102"/>
-    </mc:Choice>
-    <mc:Fallback>
-      <c:style val="2"/>
-    </mc:Fallback>
-  </mc:AlternateContent>
-  <c:chart>
-    <c:autoTitleDeleted val="1"/>
-    <c:plotArea>
-      <c:layout>
-        <c:manualLayout>
-          <c:layoutTarget val="inner"/>
-          <c:xMode val="edge"/>
-          <c:yMode val="edge"/>
-          <c:x val="8.2455523605030237E-2"/>
-          <c:y val="0.16727494328876974"/>
-          <c:w val="0.89079564466982142"/>
-          <c:h val="0.69664696219264577"/>
-        </c:manualLayout>
-      </c:layout>
-      <c:barChart>
-        <c:barDir val="col"/>
-        <c:grouping val="clustered"/>
-        <c:varyColors val="0"/>
-        <c:ser>
-          <c:idx val="0"/>
-          <c:order val="0"/>
-          <c:tx>
-            <c:strRef>
-              <c:f>Sheet1!$B$1</c:f>
-              <c:strCache>
-                <c:ptCount val="1"/>
-                <c:pt idx="0">
-                  <c:v>Revenue</c:v>
-                </c:pt>
-              </c:strCache>
-            </c:strRef>
-          </c:tx>
-          <c:spPr>
-            <a:solidFill>
-              <a:schemeClr val="accent1"/>
-            </a:solidFill>
-            <a:ln>
-              <a:noFill/>
-            </a:ln>
-            <a:effectLst/>
-          </c:spPr>
-          <c:invertIfNegative val="0"/>
-          <c:dLbls>
-            <c:spPr>
-              <a:noFill/>
-              <a:ln>
-                <a:noFill/>
-              </a:ln>
-              <a:effectLst/>
-            </c:spPr>
-            <c:txPr>
-              <a:bodyPr rot="0" spcFirstLastPara="1" vertOverflow="ellipsis" vert="horz" wrap="square" lIns="38100" tIns="19050" rIns="38100" bIns="19050" anchor="ctr" anchorCtr="1">
-                <a:spAutoFit/>
-              </a:bodyPr>
-              <a:lstStyle/>
-              <a:p>
-                <a:pPr>
-                  <a:defRPr sz="1400" b="1" i="0" u="none" strike="noStrike" kern="1200" baseline="0">
-                    <a:solidFill>
-                      <a:schemeClr val="bg1"/>
-                    </a:solidFill>
-                    <a:latin typeface="+mn-lt"/>
-                    <a:ea typeface="+mn-ea"/>
-                    <a:cs typeface="+mn-cs"/>
-                  </a:defRPr>
-                </a:pPr>
-                <a:endParaRPr lang="en-US"/>
-              </a:p>
-            </c:txPr>
-            <c:dLblPos val="inEnd"/>
-            <c:showLegendKey val="0"/>
-            <c:showVal val="1"/>
-            <c:showCatName val="0"/>
-            <c:showSerName val="0"/>
-            <c:showPercent val="0"/>
-            <c:showBubbleSize val="0"/>
-            <c:showLeaderLines val="0"/>
-            <c:extLst>
-              <c:ext uri="{CE6537A1-D6FC-4f65-9D91-7224C49458BB}">
-                <c15:showLeaderLines val="1"/>
-                <c15:leaderLines>
-                  <c:spPr>
-                    <a:ln w="9525" cap="flat" cmpd="sng" algn="ctr">
-                      <a:solidFill>
-                        <a:schemeClr val="tx1">
-                          <a:lumMod val="35000"/>
-                          <a:lumOff val="65000"/>
-                        </a:schemeClr>
-                      </a:solidFill>
-                      <a:round/>
-                    </a:ln>
-                    <a:effectLst/>
-                  </c:spPr>
-                </c15:leaderLines>
-              </c:ext>
-            </c:extLst>
-          </c:dLbls>
-          <c:cat>
-            <c:strRef>
-              <c:f>Sheet1!$A$2:$A$4</c:f>
-              <c:strCache>
-                <c:ptCount val="3"/>
-                <c:pt idx="0">
-                  <c:v>Conservative</c:v>
-                </c:pt>
-                <c:pt idx="1">
-                  <c:v>Base</c:v>
-                </c:pt>
-                <c:pt idx="2">
-                  <c:v>High scale</c:v>
-                </c:pt>
-              </c:strCache>
-            </c:strRef>
-          </c:cat>
-          <c:val>
-            <c:numRef>
-              <c:f>Sheet1!$B$2:$B$4</c:f>
-              <c:numCache>
-                <c:formatCode>General</c:formatCode>
-                <c:ptCount val="3"/>
-                <c:pt idx="0">
-                  <c:v>177</c:v>
-                </c:pt>
-                <c:pt idx="1">
-                  <c:v>488</c:v>
-                </c:pt>
-                <c:pt idx="2">
-                  <c:v>2050</c:v>
-                </c:pt>
-              </c:numCache>
-            </c:numRef>
-          </c:val>
-          <c:extLst>
-            <c:ext uri="{C3380CC4-5D6E-409C-BE32-E72D297353CC}">
-              <c16:uniqueId val="{00000000-230A-0D4B-B6D2-57328A27E5E2}"/>
-            </c:ext>
-          </c:extLst>
-        </c:ser>
-        <c:dLbls>
-          <c:showLegendKey val="0"/>
-          <c:showVal val="0"/>
-          <c:showCatName val="0"/>
-          <c:showSerName val="0"/>
-          <c:showPercent val="0"/>
-          <c:showBubbleSize val="0"/>
-        </c:dLbls>
-        <c:gapWidth val="83"/>
-        <c:axId val="1785928255"/>
-        <c:axId val="1769229823"/>
-      </c:barChart>
-      <c:lineChart>
-        <c:grouping val="standard"/>
-        <c:varyColors val="0"/>
-        <c:ser>
-          <c:idx val="1"/>
-          <c:order val="1"/>
-          <c:tx>
-            <c:strRef>
-              <c:f>Sheet1!$C$1</c:f>
-              <c:strCache>
-                <c:ptCount val="1"/>
-                <c:pt idx="0">
-                  <c:v>Listed costs</c:v>
-                </c:pt>
-              </c:strCache>
-            </c:strRef>
-          </c:tx>
-          <c:spPr>
-            <a:ln w="28575" cap="rnd">
-              <a:solidFill>
-                <a:schemeClr val="tx2">
-                  <a:lumMod val="50000"/>
-                  <a:lumOff val="50000"/>
-                </a:schemeClr>
-              </a:solidFill>
-              <a:round/>
-            </a:ln>
-            <a:effectLst/>
-          </c:spPr>
-          <c:marker>
-            <c:symbol val="circle"/>
-            <c:size val="6"/>
-            <c:spPr>
-              <a:solidFill>
-                <a:schemeClr val="tx2">
-                  <a:lumMod val="50000"/>
-                  <a:lumOff val="50000"/>
-                </a:schemeClr>
-              </a:solidFill>
-              <a:ln w="9525">
-                <a:solidFill>
-                  <a:schemeClr val="tx2">
-                    <a:lumMod val="50000"/>
-                    <a:lumOff val="50000"/>
-                  </a:schemeClr>
-                </a:solidFill>
-              </a:ln>
-              <a:effectLst/>
-            </c:spPr>
-          </c:marker>
-          <c:cat>
-            <c:strRef>
-              <c:f>Sheet1!$A$2:$A$4</c:f>
-              <c:strCache>
-                <c:ptCount val="3"/>
-                <c:pt idx="0">
-                  <c:v>Conservative</c:v>
-                </c:pt>
-                <c:pt idx="1">
-                  <c:v>Base</c:v>
-                </c:pt>
-                <c:pt idx="2">
-                  <c:v>High scale</c:v>
-                </c:pt>
-              </c:strCache>
-            </c:strRef>
-          </c:cat>
-          <c:val>
-            <c:numRef>
-              <c:f>Sheet1!$C$2:$C$4</c:f>
-              <c:numCache>
-                <c:formatCode>General</c:formatCode>
-                <c:ptCount val="3"/>
-                <c:pt idx="0">
-                  <c:v>385</c:v>
-                </c:pt>
-                <c:pt idx="1">
-                  <c:v>645</c:v>
-                </c:pt>
-                <c:pt idx="2">
-                  <c:v>1870</c:v>
                 </c:pt>
               </c:numCache>
             </c:numRef>
@@ -2758,7 +2314,7 @@
           <a:p>
             <a:r>
               <a:rPr lang="en-US" dirty="0"/>
-              <a:t>All prices and financial scenarios are illustrative USD assumptions from the business case, not market quotes or a forecast. The base case assumes 15 annual plans, 40 individual exercise workspaces, one private deployment, eight templates, and 30 support days. It produces $488,000 of modeled revenue against $645,000 of listed costs, or negative $157,000 after those costs. This excludes tax, financing, and cash timing and is not net profit.</a:t>
+              <a:t>No price, cost, revenue, purchase volume, or staffing assumption is validated. The first commercial model to investigate is a per-exercise pilot fee. Gather the actual buyer, procurement route, delivery effort, security requirements, and customer workload baseline before preparing a financial forecast.</a:t>
             </a:r>
             <a:endParaRPr lang="en-US" dirty="0"/>
           </a:p>
@@ -2846,7 +2402,7 @@
           <a:p>
             <a:r>
               <a:rPr lang="en-US" dirty="0"/>
-              <a:t>The roadmap is conditional. Start with a 90-day pilot if partners agree and privacy review permits the evidence used. Consider enterprise login, templates, integrations, or more AI only when pilot findings show what is needed and the added cost or risk is justified.</a:t>
+              <a:t>These are proposed stages, not a committed schedule. First conduct discovery with hospital-preparedness evaluators, then compare current review and DrillLoop on the same permitted records. If a partner approves access to an unfamiliar exercise, evaluate generalization and agree success thresholds together. Product hardening depends on evidence and partner requirements.</a:t>
             </a:r>
             <a:endParaRPr lang="en-US" dirty="0"/>
           </a:p>
@@ -2934,7 +2490,7 @@
           <a:p>
             <a:r>
               <a:rPr lang="en-US" dirty="0"/>
-              <a:t>This Gantt is an illustrative sequence, not a committed project schedule. Partner availability, evidence permissions, and local privacy requirements may change the timing. The decision gate is whether the pilot data supports another trial; it is not an automatic scale decision.</a:t>
+              <a:t>The sequence is illustrative and has no confirmed dates, partner, or staffing allocation. Evidence permissions and reviewer availability determine whether each step can proceed; no pilot schedule has been agreed.</a:t>
             </a:r>
             <a:endParaRPr lang="en-US" dirty="0"/>
           </a:p>
@@ -3022,7 +2578,7 @@
           <a:p>
             <a:r>
               <a:rPr lang="en-US" dirty="0"/>
-              <a:t>Close with the requested next step: authorize discovery for a 90-day, measurement-led pilot and recruit two or three willing hospital or municipal exercise teams. Use synthetic or explicitly approved records only after review. Return with evidence on reviewer workload, citation quality, and verified action closure before considering scale.</a:t>
+              <a:t>Close with the requested next step: authorize discovery and design a paired review for the hospital tabletop use case. Interview two or three prospective evaluators and observe current practice only with permission. Compare current workflow and DrillLoop on the same approved records; return with measured evidence before proposing a pilot or thresholds. No partner, date, or pilot commitment is confirmed.</a:t>
             </a:r>
             <a:endParaRPr lang="en-US" dirty="0"/>
           </a:p>
@@ -3110,7 +2666,7 @@
           <a:p>
             <a:r>
               <a:rPr lang="en-US" dirty="0"/>
-              <a:t>Use the agenda to move from what is built, to what the synthetic test measured, to what remains a market hypothesis. The figures later in the deck are either closed-fixture technical results or illustrative financial assumptions. The final section asks for a measured pilot discovery period.</a:t>
+              <a:t>Use the agenda to move from what is built, to what the synthetic test measured, to what remains a market hypothesis. The reported values are closed-fixture technical results only; there are no validated prices, costs, or sales estimates. The final section proposes discovery and a paired review; no pilot or schedule is confirmed.</a:t>
             </a:r>
             <a:endParaRPr lang="en-US" dirty="0"/>
           </a:p>
@@ -3198,7 +2754,7 @@
           <a:p>
             <a:r>
               <a:rPr lang="en-US" dirty="0"/>
-              <a:t>Summarize the MVP and the benchmark carefully: 8 of 8 log rows, 5 of 5 expected finding labels, and 9 of 9 expected evidence IDs matched in one synthetic fixture. An ID link is not a human judgment that the source supports the claim. The requested decision is to recruit pilot partners, conditional on their interest and privacy approval.</a:t>
+              <a:t>Summarize the MVP and the benchmark carefully: 8 of 8 log rows, 5 of 5 expected finding labels, and 9 of 9 expected evidence IDs matched in one synthetic fixture. An ID link is not a human judgment that the source supports the claim. The requested decision is to conduct discovery and design a paired review, subject to interest and privacy approval.</a:t>
             </a:r>
             <a:endParaRPr lang="en-US" dirty="0"/>
           </a:p>
@@ -3286,7 +2842,7 @@
           <a:p>
             <a:r>
               <a:rPr lang="en-US" dirty="0"/>
-              <a:t>The local demo includes exercise setup, evidence uploads, timeline, proposed findings, reviewer decisions, action tracking, and PDF export. The clean fixture results show that this workflow runs on its designed sample. They do not establish performance on new exercises. Hospitals and municipal teams are candidate users only; there is no measured buyer demand.</a:t>
+              <a:t>The local demo includes exercise setup, evidence uploads, timeline, proposed findings, reviewer decisions, action tracking, and PDF export. The clean fixture results show that this workflow runs on its designed sample. They do not establish performance on new exercises. Hospital-preparedness evaluators are the proposed first users; buyer roles and demand are unknown.</a:t>
             </a:r>
             <a:endParaRPr lang="en-US" dirty="0"/>
           </a:p>
@@ -3374,7 +2930,7 @@
           <a:p>
             <a:r>
               <a:rPr lang="en-US" dirty="0"/>
-              <a:t>Frame these as proposed pilot priorities. The pilot should measure evidence lookup time, evaluator corrections, citation support, and whether actions receive owners and verifiable closure proof. Use synthetic or explicitly approved records. Do not report time savings as cash savings until both the time effect and labor-cost basis are measured.</a:t>
+              <a:t>Frame these as proposed discovery and review steps. Interview two or three prospective hospital evaluators, observe a current workflow with permission, and compare the process with DrillLoop on the same permitted records. Measure time, evaluator corrections, citation support, and action completeness. Do not report savings before measuring them.</a:t>
             </a:r>
             <a:endParaRPr lang="en-US" dirty="0"/>
           </a:p>
@@ -3550,7 +3106,7 @@
           <a:p>
             <a:r>
               <a:rPr lang="en-US" dirty="0"/>
-              <a:t>Describe what is in the MVP and what is still missing. Optional faster-whisper speech transcription and local Ollama wording were not used in the benchmark. The sample fixture was deliberately built for the rules, so perfect scores do not predict performance elsewhere. No human workload or real-audio accuracy study was run.</a:t>
+              <a:t>Describe what is in the MVP and what is still missing. Optional faster-whisper speech transcription and local Ollama wording were not used in the benchmark. The sample fixture was deliberately built for the rules, so perfect scores do not predict performance elsewhere. No unfamiliar exercise, human workload, or real-audio accuracy study was run.</a:t>
             </a:r>
             <a:endParaRPr lang="en-US" dirty="0"/>
           </a:p>
@@ -3638,7 +3194,7 @@
           <a:p>
             <a:r>
               <a:rPr lang="en-US" dirty="0"/>
-              <a:t>The listed organizations are customer segments to investigate, not clients, opportunities, or a sales pipeline. No market-size or adoption numbers are included because none are validated in the available sources. Discovery should identify who uses the workflow, who buys it, what existing platforms cover, and what data controls are required.</a:t>
+              <a:t>Start with hospital-preparedness evaluators reviewing tabletop exercises. Municipal teams, airports, civil defense, training providers, defense-support teams, and critical infrastructure operators remain later hypotheses. No customer list, sales pipeline, market-size, or willingness-to-pay evidence is available.</a:t>
             </a:r>
             <a:endParaRPr lang="en-US" dirty="0"/>
           </a:p>
@@ -6252,7 +5808,7 @@
                   </a:schemeClr>
                 </a:solidFill>
               </a:rPr>
-              <a:t>Review of MVP delivery, synthetic demo results, illustrative economics, and next proof points. Customer demand, evaluator time savings, and real-world accuracy remain unvalidated.</a:t>
+              <a:t>Review of MVP delivery, synthetic demo results, commercial hypotheses, and next proof points. Pricing, delivery costs, customer demand, evaluator time savings, and real-world accuracy remain unvalidated.</a:t>
             </a:r>
           </a:p>
         </p:txBody>
@@ -8851,7 +8407,7 @@
 </file>
 
 <file path=ppt/slides/slide11.xml><?xml version="1.0" encoding="utf-8"?>
-<p:sld xmlns:a="http://schemas.openxmlformats.org/drawingml/2006/main" xmlns:a16="http://schemas.microsoft.com/office/drawing/2014/main" xmlns:c="http://schemas.openxmlformats.org/drawingml/2006/chart" xmlns:p="http://schemas.openxmlformats.org/presentationml/2006/main" xmlns:p14="http://schemas.microsoft.com/office/powerpoint/2010/main" xmlns:r="http://schemas.openxmlformats.org/officeDocument/2006/relationships">
+<p:sld xmlns:a="http://schemas.openxmlformats.org/drawingml/2006/main" xmlns:a16="http://schemas.microsoft.com/office/drawing/2014/main" xmlns:p="http://schemas.openxmlformats.org/presentationml/2006/main" xmlns:p14="http://schemas.microsoft.com/office/powerpoint/2010/main">
   <p:cSld>
     <p:spTree>
       <p:nvGrpSpPr>
@@ -8950,7 +8506,7 @@
                   <a:schemeClr val="accent1"/>
                 </a:solidFill>
               </a:rPr>
-              <a:t>Annual USD cases ($000)</a:t>
+              <a:t>Commercial model to validate</a:t>
             </a:r>
             <a:endParaRPr dirty="0">
               <a:solidFill>
@@ -8960,28 +8516,6 @@
           </a:p>
         </p:txBody>
       </p:sp>
-      <p:graphicFrame>
-        <p:nvGraphicFramePr>
-          <p:cNvPr id="4" name="Chart 3">
-            <a:extLst>
-              <a:ext uri="{FF2B5EF4-FFF2-40B4-BE49-F238E27FC236}">
-                <a16:creationId id="{F9ECF619-B138-985C-78A5-B4A36DC109EB}"/>
-              </a:ext>
-            </a:extLst>
-          </p:cNvPr>
-          <p:cNvGraphicFramePr/>
-          <p:nvPr/>
-        </p:nvGraphicFramePr>
-        <p:xfrm>
-          <a:off x="408690" y="1023105"/>
-          <a:ext cx="5124182" cy="5225194"/>
-        </p:xfrm>
-        <a:graphic>
-          <a:graphicData uri="http://schemas.openxmlformats.org/drawingml/2006/chart">
-            <c:chart r:id="rId3"/>
-          </a:graphicData>
-        </a:graphic>
-      </p:graphicFrame>
       <p:sp>
         <p:nvSpPr>
           <p:cNvPr id="5" name="Footer Placeholder 4">
@@ -9291,7 +8825,7 @@
                 <a:cs typeface="Helvetica Neue" panose="02000503000000020004" pitchFamily="2" charset="0"/>
                 <a:sym typeface="OpenAI Sans"/>
               </a:rPr>
-              <a:t>$488k</a:t>
+              <a:t>TBD</a:t>
             </a:r>
             <a:endParaRPr lang="en-US" sz="6200" dirty="0">
               <a:solidFill>
@@ -9515,7 +9049,7 @@
                 <a:cs typeface="Helvetica Neue" panose="02000503000000020004" pitchFamily="2" charset="0"/>
                 <a:sym typeface="OpenAI Sans"/>
               </a:rPr>
-              <a:t>Base-case revenue under listed assumptions.</a:t>
+              <a:t>No customer demand, revenue, or delivery-cost evidence.</a:t>
             </a:r>
             <a:br>
               <a:rPr lang="en-US" sz="1600" dirty="0">
@@ -9848,7 +9382,7 @@
                 <a:cs typeface="Helvetica Neue" panose="02000503000000020004" pitchFamily="2" charset="0"/>
                 <a:sym typeface="OpenAI Sans"/>
               </a:rPr>
-              <a:t>Loss</a:t>
+              <a:t>Pilot fee</a:t>
             </a:r>
             <a:endParaRPr lang="en-US" sz="6200" dirty="0">
               <a:solidFill>
@@ -10072,7 +9606,7 @@
                 <a:cs typeface="Helvetica Neue" panose="02000503000000020004" pitchFamily="2" charset="0"/>
                 <a:sym typeface="OpenAI Sans"/>
               </a:rPr>
-              <a:t>$157k shortfall after costs; not net profit.</a:t>
+              <a:t>Per-exercise pilot fee.</a:t>
             </a:r>
             <a:br>
               <a:rPr lang="en-US" sz="1600" dirty="0">
@@ -10332,7 +9866,7 @@
                 <a:cs typeface="Helvetica Neue" panose="02000503000000020004" pitchFamily="2" charset="0"/>
                 <a:sym typeface="OpenAI Sans"/>
               </a:rPr>
-              <a:t>Base case: 15 annual plans, 40 exercises, one private deployment, eight templates, and 30 support days. Revenue / listed costs: conservative $177k / $385k; base $488k / $645k; high scale $2.05m / $1.87m. Planning assumptions, not a forecast; excludes tax and cash timing.</a:t>
+              <a:t>Annual subscriptions, private deployment, templates, and support are later hypotheses. Confirm buyer, purchasing route, and delivery needs before modeling economics.</a:t>
             </a:r>
             <a:r>
               <a:rPr lang="en-US" sz="1600" dirty="0" err="1">
@@ -10574,6 +10108,114 @@
               </a:rPr>
               <a:t/>
             </a:r>
+          </a:p>
+        </p:txBody>
+      </p:sp>
+      <p:sp>
+        <p:nvSpPr>
+          <p:cNvPr id="534" name="Commercial inputs callout"/>
+          <p:cNvSpPr txBox="1"/>
+          <p:nvPr/>
+        </p:nvSpPr>
+        <p:spPr>
+          <a:xfrm>
+            <a:off x="450000" y="1180000"/>
+            <a:ext cx="5400000" cy="5150000"/>
+          </a:xfrm>
+          <a:prstGeom prst="roundRect">
+            <a:avLst/>
+          </a:prstGeom>
+          <a:solidFill>
+            <a:schemeClr val="lt1"/>
+          </a:solidFill>
+          <a:ln w="12700">
+            <a:solidFill>
+              <a:schemeClr val="accent2"/>
+            </a:solidFill>
+          </a:ln>
+        </p:spPr>
+        <p:txBody>
+          <a:bodyPr wrap="square" lIns="285750" tIns="228600" rIns="285750" bIns="228600" anchor="ctr"/>
+          <a:lstStyle/>
+          <a:p>
+            <a:pPr algn="l">
+              <a:lnSpc>
+                <a:spcPct val="105000"/>
+              </a:lnSpc>
+              <a:spcAft>
+                <a:spcPts val="1000"/>
+              </a:spcAft>
+            </a:pPr>
+            <a:r>
+              <a:rPr lang="en-US" sz="2200" b="1">
+                <a:solidFill>
+                  <a:schemeClr val="accent1"/>
+                </a:solidFill>
+                <a:latin typeface="+mn-lt"/>
+              </a:rPr>
+              <a:t>Evidence to collect</a:t>
+            </a:r>
+            <a:endParaRPr lang="en-US" sz="2200"/>
+          </a:p>
+          <a:p>
+            <a:pPr algn="l">
+              <a:lnSpc>
+                <a:spcPct val="105000"/>
+              </a:lnSpc>
+              <a:spcAft>
+                <a:spcPts val="1000"/>
+              </a:spcAft>
+            </a:pPr>
+            <a:r>
+              <a:rPr lang="en-US" sz="1700">
+                <a:solidFill>
+                  <a:schemeClr val="tx1"/>
+                </a:solidFill>
+                <a:latin typeface="+mn-lt"/>
+              </a:rPr>
+              <a:t>Who prepares, approves, and pays?</a:t>
+            </a:r>
+            <a:endParaRPr lang="en-US" sz="1700"/>
+          </a:p>
+          <a:p>
+            <a:pPr algn="l">
+              <a:lnSpc>
+                <a:spcPct val="105000"/>
+              </a:lnSpc>
+              <a:spcAft>
+                <a:spcPts val="1000"/>
+              </a:spcAft>
+            </a:pPr>
+            <a:r>
+              <a:rPr lang="en-US" sz="1700">
+                <a:solidFill>
+                  <a:schemeClr val="tx1"/>
+                </a:solidFill>
+                <a:latin typeface="+mn-lt"/>
+              </a:rPr>
+              <a:t>What setup, security, hosting, and support are required?</a:t>
+            </a:r>
+            <a:endParaRPr lang="en-US" sz="1700"/>
+          </a:p>
+          <a:p>
+            <a:pPr algn="l">
+              <a:lnSpc>
+                <a:spcPct val="105000"/>
+              </a:lnSpc>
+              <a:spcAft>
+                <a:spcPts val="1000"/>
+              </a:spcAft>
+            </a:pPr>
+            <a:r>
+              <a:rPr lang="en-US" sz="1700">
+                <a:solidFill>
+                  <a:schemeClr val="tx1"/>
+                </a:solidFill>
+                <a:latin typeface="+mn-lt"/>
+              </a:rPr>
+              <a:t>What does the current workflow take, and where are corrections made?</a:t>
+            </a:r>
+            <a:endParaRPr lang="en-US" sz="1700"/>
           </a:p>
         </p:txBody>
       </p:sp>
@@ -10662,7 +10304,7 @@
                 <a:cs typeface="Helvetica Neue" panose="02000503000000020004" pitchFamily="2" charset="0"/>
                 <a:sym typeface="OpenAI Sans"/>
               </a:rPr>
-              <a:t>Run a measured pilot</a:t>
+              <a:t>Learn the workflow</a:t>
             </a:r>
           </a:p>
           <a:p>
@@ -10683,7 +10325,7 @@
                 <a:cs typeface="Helvetica Neue" panose="02000503000000020004" pitchFamily="2" charset="0"/>
                 <a:sym typeface="OpenAI Sans"/>
               </a:rPr>
-              <a:t>Work with 2–3 willing hospital or municipal teams. Measure source lookup, reviewer edits, citation support, action ownership, and verified closure.</a:t>
+              <a:t>Interview 2–3 prospective hospital evaluators; observe current review with permission and identify approver and budget roles.</a:t>
             </a:r>
             <a:r>
               <a:rPr lang="en-US" dirty="0" err="1">
@@ -10862,7 +10504,7 @@
                   <a:schemeClr val="accent1"/>
                 </a:solidFill>
               </a:rPr>
-              <a:t>Next 12 months: validate before scaling</a:t>
+              <a:t>Proposed stages: discover, compare, then decide</a:t>
             </a:r>
           </a:p>
         </p:txBody>
@@ -10920,7 +10562,7 @@
                 <a:cs typeface="Helvetica Neue" panose="02000503000000020004" pitchFamily="2" charset="0"/>
                 <a:sym typeface="OpenAI Sans"/>
               </a:rPr>
-              <a:t>Harden what the pilot needs</a:t>
+              <a:t>Compare on the same records</a:t>
             </a:r>
           </a:p>
           <a:p>
@@ -10956,7 +10598,7 @@
                 <a:cs typeface="Helvetica Neue" panose="02000503000000020004" pitchFamily="2" charset="0"/>
                 <a:sym typeface="OpenAI Sans"/>
               </a:rPr>
-              <a:t>If the evidence supports it, assess organization login, configurable templates, private hosting, and integrations.</a:t>
+              <a:t>With permission, compare current practice and DrillLoop; measure time, corrections, citation support, and action fields.</a:t>
             </a:r>
             <a:r>
               <a:rPr kumimoji="0" lang="en-US" sz="1600" b="0" i="0" u="none" strike="noStrike" kern="1200" cap="none" spc="0" normalizeH="0" baseline="0" noProof="0" dirty="0" err="1">
@@ -11252,7 +10894,7 @@
                 <a:cs typeface="Helvetica Neue" panose="02000503000000020004" pitchFamily="2" charset="0"/>
                 <a:sym typeface="OpenAI Sans"/>
               </a:rPr>
-              <a:t>Decide whether to add AI</a:t>
+              <a:t>Test generalization</a:t>
             </a:r>
           </a:p>
           <a:p>
@@ -11288,7 +10930,7 @@
                 <a:cs typeface="Helvetica Neue" panose="02000503000000020004" pitchFamily="2" charset="0"/>
                 <a:sym typeface="OpenAI Sans"/>
               </a:rPr>
-              <a:t>Evaluate optional speech or writing models only if measured quality, privacy controls, and reviewer workload justify them.</a:t>
+              <a:t>If approved records are available, test evaluator-labeled evidence from an unfamiliar exercise and agree next thresholds with a partner.</a:t>
             </a:r>
             <a:r>
               <a:rPr kumimoji="0" lang="en-US" b="0" i="0" u="none" strike="noStrike" kern="1200" cap="none" spc="0" normalizeH="0" baseline="0" noProof="0" dirty="0" err="1">
@@ -11940,7 +11582,7 @@
                 <a:cs typeface="Helvetica Neue" panose="02000503000000020004" pitchFamily="2" charset="0"/>
                 <a:sym typeface="OpenAI Sans"/>
               </a:rPr>
-              <a:t>0–3 months</a:t>
+              <a:t>Discovery</a:t>
             </a:r>
           </a:p>
         </p:txBody>
@@ -12158,7 +11800,7 @@
                 <a:cs typeface="Helvetica Neue" panose="02000503000000020004" pitchFamily="2" charset="0"/>
                 <a:sym typeface="OpenAI Sans"/>
               </a:rPr>
-              <a:t>3–6 months</a:t>
+              <a:t>Paired review</a:t>
             </a:r>
           </a:p>
         </p:txBody>
@@ -12376,7 +12018,7 @@
                 <a:cs typeface="Helvetica Neue" panose="02000503000000020004" pitchFamily="2" charset="0"/>
                 <a:sym typeface="OpenAI Sans"/>
               </a:rPr>
-              <a:t>6–12 months</a:t>
+              <a:t>Next decision</a:t>
             </a:r>
           </a:p>
         </p:txBody>
@@ -12519,7 +12161,7 @@
                   <a:schemeClr val="accent1"/>
                 </a:solidFill>
               </a:rPr>
-              <a:t>Illustrative 90-day pilot workplan</a:t>
+              <a:t>Illustrative discovery and review sequence</a:t>
             </a:r>
             <a:endParaRPr dirty="0">
               <a:solidFill>
@@ -12617,7 +12259,7 @@
                             </a:schemeClr>
                           </a:solidFill>
                         </a:rPr>
-                        <a:t>Weeks 1–2</a:t>
+                        <a:t>Scope</a:t>
                       </a:r>
                       <a:endParaRPr sz="1600" dirty="0">
                         <a:solidFill>
@@ -12697,7 +12339,7 @@
                             </a:schemeClr>
                           </a:solidFill>
                         </a:rPr>
-                        <a:t>Weeks 3–4</a:t>
+                        <a:t>Interview</a:t>
                       </a:r>
                       <a:endParaRPr sz="1600" dirty="0">
                         <a:solidFill>
@@ -12777,7 +12419,7 @@
                             </a:schemeClr>
                           </a:solidFill>
                         </a:rPr>
-                        <a:t>Weeks 5–6</a:t>
+                        <a:t>Compare</a:t>
                       </a:r>
                       <a:endParaRPr sz="1600" dirty="0">
                         <a:solidFill>
@@ -12857,7 +12499,7 @@
                             </a:schemeClr>
                           </a:solidFill>
                         </a:rPr>
-                        <a:t>Weeks 7–9</a:t>
+                        <a:t>Measure</a:t>
                       </a:r>
                       <a:endParaRPr sz="1600" dirty="0">
                         <a:solidFill>
@@ -12937,7 +12579,7 @@
                             </a:schemeClr>
                           </a:solidFill>
                         </a:rPr>
-                        <a:t>Weeks 10–12</a:t>
+                        <a:t>Decide</a:t>
                       </a:r>
                       <a:endParaRPr sz="1600" dirty="0">
                         <a:solidFill>
@@ -13050,7 +12692,7 @@
                 <a:cs typeface="Helvetica Neue"/>
                 <a:sym typeface="Helvetica Neue"/>
               </a:rPr>
-              <a:t>Score citations and reviewer corrections</a:t>
+              <a:t>Measure citations, time, and reviewer corrections</a:t>
             </a:r>
           </a:p>
         </p:txBody>
@@ -13102,7 +12744,7 @@
                 <a:cs typeface="Helvetica Neue"/>
                 <a:sym typeface="Helvetica Neue"/>
               </a:rPr>
-              <a:t>Decision gate: continue only after approvals and evidence review</a:t>
+              <a:t>Propose a pilot only after access, partner interest, and review needs are clear</a:t>
             </a:r>
             <a:endParaRPr sz="1500" dirty="0">
               <a:solidFill>
@@ -13161,7 +12803,7 @@
                 <a:cs typeface="Helvetica Neue"/>
                 <a:sym typeface="Helvetica Neue"/>
               </a:rPr>
-              <a:t>Check action owners and closure evidence</a:t>
+              <a:t>Check action ownership and closure evidence</a:t>
             </a:r>
           </a:p>
         </p:txBody>
@@ -13211,7 +12853,7 @@
                 <a:cs typeface="Helvetica Neue"/>
                 <a:sym typeface="Helvetica Neue"/>
               </a:rPr>
-              <a:t>Run matched evidence-review sessions</a:t>
+              <a:t>Compare both workflows on the same records</a:t>
             </a:r>
           </a:p>
         </p:txBody>
@@ -13261,7 +12903,7 @@
                 <a:cs typeface="Helvetica Neue"/>
                 <a:sym typeface="Helvetica Neue"/>
               </a:rPr>
-              <a:t>Recruit evaluators; document today's workflow</a:t>
+              <a:t>Interview evaluators; map roles and current workflow</a:t>
             </a:r>
           </a:p>
         </p:txBody>
@@ -13311,7 +12953,7 @@
                 <a:cs typeface="Helvetica Neue"/>
                 <a:sym typeface="Helvetica Neue"/>
               </a:rPr>
-              <a:t>Confirm willing teams and approve data use</a:t>
+              <a:t>Confirm use case and evidence permissions</a:t>
             </a:r>
             <a:endParaRPr sz="1500" dirty="0">
               <a:solidFill>
@@ -13467,7 +13109,7 @@
                   </a:schemeClr>
                 </a:solidFill>
               </a:rPr>
-              <a:t>Authorize discovery for a 90-day, measurement-led pilot.</a:t>
+              <a:t>Authorize discovery and a paired-review design for the hospital tabletop use case.</a:t>
             </a:r>
           </a:p>
           <a:p>
@@ -13484,7 +13126,7 @@
                   </a:schemeClr>
                 </a:solidFill>
               </a:rPr>
-              <a:t>Recruit 2–3 hospital or municipal teams if they are willing; use synthetic or specifically approved records after privacy review.</a:t>
+              <a:t>Interview 2–3 prospective evaluators and observe an existing review only with permission; confirm approver, budget owner, and evidence controls.</a:t>
             </a:r>
           </a:p>
           <a:p>
@@ -13501,7 +13143,7 @@
                   </a:schemeClr>
                 </a:solidFill>
               </a:rPr>
-              <a:t>Return with reviewer workload, citation quality, and closure-verification results before any decision to scale.</a:t>
+              <a:t>Compare current practice and DrillLoop on the same permitted records, then return with findings before proposing a pilot or success thresholds.</a:t>
             </a:r>
           </a:p>
         </p:txBody>
@@ -14688,7 +14330,7 @@
                           <a:ea typeface="+mn-ea"/>
                           <a:cs typeface="+mn-cs"/>
                         </a:rPr>
-                        <a:t>Pricing assumptions</a:t>
+                        <a:t>Commercial model</a:t>
                       </a:r>
                     </a:p>
                   </a:txBody>
@@ -14761,7 +14403,7 @@
                           <a:ea typeface="Roboto Medium" panose="02000000000000000000" pitchFamily="2" charset="0"/>
                           <a:cs typeface="+mn-cs"/>
                         </a:rPr>
-                        <a:t>Illustrative</a:t>
+                        <a:t>Hypothesis</a:t>
                       </a:r>
                     </a:p>
                   </a:txBody>
@@ -14989,7 +14631,7 @@
                           <a:ea typeface="Roboto Medium" panose="02000000000000000000" pitchFamily="2" charset="0"/>
                           <a:cs typeface="+mn-cs"/>
                         </a:rPr>
-                        <a:t>Next 90 days</a:t>
+                        <a:t>Discovery</a:t>
                       </a:r>
                     </a:p>
                   </a:txBody>
@@ -17469,7 +17111,7 @@
                 <a:cs typeface="Helvetica Neue" panose="02000503000000020004" pitchFamily="2" charset="0"/>
                 <a:sym typeface="OpenAI Sans"/>
               </a:rPr>
-              <a:t>Authorize discovery for a 90-day pilot with 2–3 hospital or municipal exercise teams, subject to partner interest and privacy approval. Measure source lookup, citation support, reviewer edits, action ownership, and verified closure.</a:t>
+              <a:t>Authorize discovery for a hospital-tabletop review. Interview 2–3 prospective evaluators; compare current workflow with DrillLoop on the same permitted records, then test an unfamiliar exercise if access is approved.</a:t>
             </a:r>
             <a:r>
               <a:rPr lang="en-US" sz="1600" dirty="0" err="1">
@@ -21276,7 +20918,7 @@
                 <a:cs typeface="Helvetica Neue" panose="02000503000000020004" pitchFamily="2" charset="0"/>
                 <a:sym typeface="OpenAI Sans"/>
               </a:rPr>
-              <a:t>Hospitals and municipal teams are candidate pilots; demand and willingness to pay are untested.</a:t>
+              <a:t>Hospital-preparedness evaluators are the proposed first users; approver, budget owner, and purchasing route are unknown.</a:t>
             </a:r>
             <a:r>
               <a:rPr kumimoji="0" lang="en-US" sz="1600" b="0" i="0" u="none" strike="noStrike" kern="1200" cap="none" spc="0" normalizeH="0" baseline="0" noProof="0" dirty="0" err="1">
@@ -21869,7 +21511,7 @@
                 <a:cs typeface="Helvetica Neue" panose="02000503000000020004" pitchFamily="2" charset="0"/>
                 <a:sym typeface="OpenAI Sans"/>
               </a:rPr>
-              <a:t>Real data needs approval. Citation quality, reviewer edits, and action closure need pilot validation.</a:t>
+              <a:t>Security controls and performance on unfamiliar exercises need review; use synthetic or explicitly approved records.</a:t>
             </a:r>
             <a:r>
               <a:rPr kumimoji="0" lang="en-US" sz="1600" b="0" i="0" u="none" strike="noStrike" kern="1200" cap="none" spc="0" normalizeH="0" baseline="0" noProof="0" dirty="0" err="1">
@@ -22600,7 +22242,7 @@
                 <a:cs typeface="Helvetica Neue" panose="02000503000000020004" pitchFamily="2" charset="0"/>
                 <a:sym typeface="OpenAI Sans"/>
               </a:rPr>
-              <a:t>Can evaluators find and verify source evidence faster?</a:t>
+              <a:t>Can hospital evaluators verify source evidence efficiently?</a:t>
             </a:r>
             <a:r>
               <a:rPr lang="en-US" sz="1600" dirty="0" err="1">
@@ -23182,7 +22824,7 @@
                 <a:cs typeface="Helvetica Neue" panose="02000503000000020004" pitchFamily="2" charset="0"/>
                 <a:sym typeface="OpenAI Sans"/>
               </a:rPr>
-              <a:t>Do cited records support each draft finding, and can teams assign and verify improvement tasks? Use synthetic or specifically approved records. Compare the process with current manual review; do not assume savings before measuring them.</a:t>
+              <a:t>Compare current practice and DrillLoop on the same permitted records. Check whether citations support each finding and actions have owners and closure proof; measure time and corrections without assuming savings.</a:t>
             </a:r>
             <a:r>
               <a:rPr lang="en-US" sz="1600" dirty="0" err="1">
@@ -23953,7 +23595,7 @@
                 <a:cs typeface="Helvetica Neue" panose="02000503000000020004" pitchFamily="2" charset="0"/>
                 <a:sym typeface="OpenAI Sans"/>
               </a:rPr>
-              <a:t>A 90-day pilot should answer three practical questions:</a:t>
+              <a:t>Discovery and a paired review should answer three practical questions:</a:t>
             </a:r>
             <a:r>
               <a:rPr lang="en-US" sz="2000" dirty="0" err="1">
@@ -24288,7 +23930,7 @@
                 <a:cs typeface="Helvetica Neue" panose="02000503000000020004" pitchFamily="2" charset="0"/>
                 <a:sym typeface="OpenAI Sans"/>
               </a:rPr>
-              <a:t>Seek 2–3 willing hospital or municipal exercise teams and an evaluator contact.</a:t>
+              <a:t>Interview 2–3 hospital-preparedness evaluators; observe the current review with permission.</a:t>
             </a:r>
             <a:r>
               <a:rPr kumimoji="0" lang="en-US" sz="1400" b="0" i="0" u="none" strike="noStrike" kern="1200" cap="none" spc="0" normalizeH="0" baseline="0" noProof="0" dirty="0" err="1">
@@ -24654,7 +24296,7 @@
                 <a:cs typeface="Helvetica Neue Medium" panose="02000503000000020004" pitchFamily="2" charset="0"/>
                 <a:sym typeface="OpenAI Sans"/>
               </a:rPr>
-              <a:t>Recruit pilot teams</a:t>
+              <a:t>Interview users</a:t>
             </a:r>
           </a:p>
         </p:txBody>
@@ -28407,7 +28049,7 @@
                 <a:cs typeface="Helvetica Neue" panose="02000503000000020004" pitchFamily="2" charset="0"/>
                 <a:sym typeface="OpenAI Sans"/>
               </a:rPr>
-              <a:t>The pilot should test source traceability, reviewer confidence, and action follow-through in existing exercise workflows.</a:t>
+              <a:t>A proposed review should test source traceability, evaluator corrections, and action follow-through in an existing exercise workflow.</a:t>
             </a:r>
             <a:r>
               <a:rPr lang="en-US" sz="1600" dirty="0" err="1">
@@ -30233,7 +29875,7 @@
                 <a:cs typeface="Helvetica Neue" panose="02000503000000020004" pitchFamily="2" charset="0"/>
                 <a:sym typeface="OpenAI Sans"/>
               </a:rPr>
-              <a:t>Reviewers can accept or reject drafts, assign owners and due dates, specify how completion will be checked, record closure proof, and export a report. A simple local database supports the demo; a deployment-ready database option is included.</a:t>
+              <a:t>Reviewers can accept or reject drafts, assign owners and due dates, specify how completion will be checked, record closure proof, and export a report. SQLite supports the local demo; PostgreSQL is available in Compose for deployment experiments.</a:t>
             </a:r>
             <a:r>
               <a:rPr lang="en-US" sz="1400" dirty="0" err="1">
@@ -33809,7 +33451,7 @@
                 <a:cs typeface="Helvetica Neue" panose="02000503000000020004" pitchFamily="2" charset="0"/>
                 <a:sym typeface="OpenAI Sans"/>
               </a:rPr>
-              <a:t>Potential segments include hospitals, municipal emergency teams, airports, civil defense and disaster agencies, training providers, defense-support teams, and critical infrastructure operators. No customer list, sales pipeline, market-size estimate, or willingness-to-pay evidence is available. Validate use cases and purchasing paths before forecasting adoption.</a:t>
+              <a:t>Start with hospital-preparedness evaluators reviewing tabletop exercises. Municipal teams, airports, civil defense and disaster agencies, training providers, defense-support teams, and critical infrastructure operators are later hypotheses. No customer list, sales pipeline, market-size estimate, or willingness-to-pay evidence is available.</a:t>
             </a:r>
           </a:p>
           <a:p>

</xml_diff>